<commit_message>
made an html-based report that updates each test
</commit_message>
<xml_diff>
--- a/doc/Automated-End-to-End-Testing-of-GOGcom.pptx
+++ b/doc/Automated-End-to-End-Testing-of-GOGcom.pptx
@@ -5,7 +5,7 @@
     <p:sldMasterId id="2147483648" r:id="rId1"/>
   </p:sldMasterIdLst>
   <p:notesMasterIdLst>
-    <p:notesMasterId r:id="rId13"/>
+    <p:notesMasterId r:id="rId15"/>
   </p:notesMasterIdLst>
   <p:sldIdLst>
     <p:sldId id="256" r:id="rId2"/>
@@ -18,14 +18,16 @@
     <p:sldId id="263" r:id="rId9"/>
     <p:sldId id="264" r:id="rId10"/>
     <p:sldId id="265" r:id="rId11"/>
-    <p:sldId id="266" r:id="rId12"/>
+    <p:sldId id="267" r:id="rId12"/>
+    <p:sldId id="268" r:id="rId13"/>
+    <p:sldId id="269" r:id="rId14"/>
   </p:sldIdLst>
   <p:sldSz cx="14630400" cy="8229600"/>
   <p:notesSz cx="8229600" cy="14630400"/>
   <p:embeddedFontLst>
     <p:embeddedFont>
       <p:font typeface="Inter" panose="020B0604020202020204" charset="0"/>
-      <p:regular r:id="rId14"/>
+      <p:regular r:id="rId16"/>
     </p:embeddedFont>
   </p:embeddedFontLst>
   <p:defaultTextStyle>
@@ -424,6 +426,114 @@
 </p:notes>
 </file>
 
+<file path=ppt/notesSlides/notesSlide11.xml><?xml version="1.0" encoding="utf-8"?>
+<p:notes xmlns:a="http://schemas.openxmlformats.org/drawingml/2006/main" xmlns:r="http://schemas.openxmlformats.org/officeDocument/2006/relationships" xmlns:p="http://schemas.openxmlformats.org/presentationml/2006/main">
+  <p:cSld>
+    <p:spTree>
+      <p:nvGrpSpPr>
+        <p:cNvPr id="1" name="">
+          <a:extLst>
+            <a:ext uri="{FF2B5EF4-FFF2-40B4-BE49-F238E27FC236}">
+              <a16:creationId xmlns:a16="http://schemas.microsoft.com/office/drawing/2014/main" id="{EA5165A6-3BEB-DA4E-C57D-02F067FA43A2}"/>
+            </a:ext>
+          </a:extLst>
+        </p:cNvPr>
+        <p:cNvGrpSpPr/>
+        <p:nvPr/>
+      </p:nvGrpSpPr>
+      <p:grpSpPr>
+        <a:xfrm>
+          <a:off x="0" y="0"/>
+          <a:ext cx="0" cy="0"/>
+          <a:chOff x="0" y="0"/>
+          <a:chExt cx="0" cy="0"/>
+        </a:xfrm>
+      </p:grpSpPr>
+      <p:sp>
+        <p:nvSpPr>
+          <p:cNvPr id="2" name="Slide Image Placeholder 1">
+            <a:extLst>
+              <a:ext uri="{FF2B5EF4-FFF2-40B4-BE49-F238E27FC236}">
+                <a16:creationId xmlns:a16="http://schemas.microsoft.com/office/drawing/2014/main" id="{2B6CC053-3896-1B39-EE82-A114A9A37849}"/>
+              </a:ext>
+            </a:extLst>
+          </p:cNvPr>
+          <p:cNvSpPr>
+            <a:spLocks noGrp="1" noRot="1" noChangeAspect="1"/>
+          </p:cNvSpPr>
+          <p:nvPr>
+            <p:ph type="sldImg"/>
+          </p:nvPr>
+        </p:nvSpPr>
+        <p:spPr/>
+      </p:sp>
+      <p:sp>
+        <p:nvSpPr>
+          <p:cNvPr id="3" name="Notes Placeholder 2">
+            <a:extLst>
+              <a:ext uri="{FF2B5EF4-FFF2-40B4-BE49-F238E27FC236}">
+                <a16:creationId xmlns:a16="http://schemas.microsoft.com/office/drawing/2014/main" id="{535BA64F-EF41-F326-57DE-65EEE9AD5A1D}"/>
+              </a:ext>
+            </a:extLst>
+          </p:cNvPr>
+          <p:cNvSpPr>
+            <a:spLocks noGrp="1"/>
+          </p:cNvSpPr>
+          <p:nvPr>
+            <p:ph type="body" idx="1"/>
+          </p:nvPr>
+        </p:nvSpPr>
+        <p:spPr/>
+        <p:txBody>
+          <a:bodyPr/>
+          <a:lstStyle/>
+          <a:p>
+            <a:endParaRPr lang="en-US" dirty="0"/>
+          </a:p>
+        </p:txBody>
+      </p:sp>
+      <p:sp>
+        <p:nvSpPr>
+          <p:cNvPr id="4" name="Slide Number Placeholder 3">
+            <a:extLst>
+              <a:ext uri="{FF2B5EF4-FFF2-40B4-BE49-F238E27FC236}">
+                <a16:creationId xmlns:a16="http://schemas.microsoft.com/office/drawing/2014/main" id="{7356AEC8-F20F-3EFD-F5A1-3BA8AB24A52B}"/>
+              </a:ext>
+            </a:extLst>
+          </p:cNvPr>
+          <p:cNvSpPr>
+            <a:spLocks noGrp="1"/>
+          </p:cNvSpPr>
+          <p:nvPr>
+            <p:ph type="sldNum" sz="quarter" idx="10"/>
+          </p:nvPr>
+        </p:nvSpPr>
+        <p:spPr/>
+        <p:txBody>
+          <a:bodyPr/>
+          <a:lstStyle/>
+          <a:p>
+            <a:fld id="{F7021451-1387-4CA6-816F-3879F97B5CBC}" type="slidenum">
+              <a:rPr lang="en-US"/>
+              <a:t>11</a:t>
+            </a:fld>
+            <a:endParaRPr lang="en-US"/>
+          </a:p>
+        </p:txBody>
+      </p:sp>
+    </p:spTree>
+    <p:extLst>
+      <p:ext uri="{BB962C8B-B14F-4D97-AF65-F5344CB8AC3E}">
+        <p14:creationId xmlns:p14="http://schemas.microsoft.com/office/powerpoint/2010/main" val="685451310"/>
+      </p:ext>
+    </p:extLst>
+  </p:cSld>
+  <p:clrMapOvr>
+    <a:masterClrMapping/>
+  </p:clrMapOvr>
+</p:notes>
+</file>
+
 <file path=ppt/notesSlides/notesSlide2.xml><?xml version="1.0" encoding="utf-8"?>
 <p:notes xmlns:a="http://schemas.openxmlformats.org/drawingml/2006/main" xmlns:r="http://schemas.openxmlformats.org/officeDocument/2006/relationships" xmlns:p="http://schemas.openxmlformats.org/presentationml/2006/main">
   <p:cSld>
@@ -1162,6 +1272,13 @@
           </a:solidFill>
           <a:ln/>
         </p:spPr>
+        <p:txBody>
+          <a:bodyPr/>
+          <a:lstStyle/>
+          <a:p>
+            <a:endParaRPr lang="en-US"/>
+          </a:p>
+        </p:txBody>
       </p:sp>
       <p:sp>
         <p:nvSpPr>
@@ -1182,6 +1299,13 @@
           </a:solidFill>
           <a:ln/>
         </p:spPr>
+        <p:txBody>
+          <a:bodyPr/>
+          <a:lstStyle/>
+          <a:p>
+            <a:endParaRPr lang="en-US"/>
+          </a:p>
+        </p:txBody>
       </p:sp>
       <p:pic>
         <p:nvPicPr>
@@ -1253,6 +1377,13 @@
           </a:solidFill>
           <a:ln/>
         </p:spPr>
+        <p:txBody>
+          <a:bodyPr/>
+          <a:lstStyle/>
+          <a:p>
+            <a:endParaRPr lang="en-US"/>
+          </a:p>
+        </p:txBody>
       </p:sp>
       <p:sp>
         <p:nvSpPr>
@@ -1273,6 +1404,13 @@
           </a:solidFill>
           <a:ln/>
         </p:spPr>
+        <p:txBody>
+          <a:bodyPr/>
+          <a:lstStyle/>
+          <a:p>
+            <a:endParaRPr lang="en-US"/>
+          </a:p>
+        </p:txBody>
       </p:sp>
       <p:pic>
         <p:nvPicPr>
@@ -1449,6 +1587,13 @@
           </a:solidFill>
           <a:ln/>
         </p:spPr>
+        <p:txBody>
+          <a:bodyPr/>
+          <a:lstStyle/>
+          <a:p>
+            <a:endParaRPr lang="en-US"/>
+          </a:p>
+        </p:txBody>
       </p:sp>
       <p:sp>
         <p:nvSpPr>
@@ -1469,6 +1614,13 @@
           </a:solidFill>
           <a:ln/>
         </p:spPr>
+        <p:txBody>
+          <a:bodyPr/>
+          <a:lstStyle/>
+          <a:p>
+            <a:endParaRPr lang="en-US"/>
+          </a:p>
+        </p:txBody>
       </p:sp>
       <p:pic>
         <p:nvPicPr>
@@ -1540,6 +1692,13 @@
           </a:solidFill>
           <a:ln/>
         </p:spPr>
+        <p:txBody>
+          <a:bodyPr/>
+          <a:lstStyle/>
+          <a:p>
+            <a:endParaRPr lang="en-US"/>
+          </a:p>
+        </p:txBody>
       </p:sp>
       <p:sp>
         <p:nvSpPr>
@@ -1560,6 +1719,13 @@
           </a:solidFill>
           <a:ln/>
         </p:spPr>
+        <p:txBody>
+          <a:bodyPr/>
+          <a:lstStyle/>
+          <a:p>
+            <a:endParaRPr lang="en-US"/>
+          </a:p>
+        </p:txBody>
       </p:sp>
       <p:pic>
         <p:nvPicPr>
@@ -1631,6 +1797,13 @@
           </a:solidFill>
           <a:ln/>
         </p:spPr>
+        <p:txBody>
+          <a:bodyPr/>
+          <a:lstStyle/>
+          <a:p>
+            <a:endParaRPr lang="en-US"/>
+          </a:p>
+        </p:txBody>
       </p:sp>
       <p:sp>
         <p:nvSpPr>
@@ -1651,6 +1824,13 @@
           </a:solidFill>
           <a:ln/>
         </p:spPr>
+        <p:txBody>
+          <a:bodyPr/>
+          <a:lstStyle/>
+          <a:p>
+            <a:endParaRPr lang="en-US"/>
+          </a:p>
+        </p:txBody>
       </p:sp>
       <p:pic>
         <p:nvPicPr>
@@ -1722,6 +1902,13 @@
           </a:solidFill>
           <a:ln/>
         </p:spPr>
+        <p:txBody>
+          <a:bodyPr/>
+          <a:lstStyle/>
+          <a:p>
+            <a:endParaRPr lang="en-US"/>
+          </a:p>
+        </p:txBody>
       </p:sp>
       <p:sp>
         <p:nvSpPr>
@@ -1742,6 +1929,13 @@
           </a:solidFill>
           <a:ln/>
         </p:spPr>
+        <p:txBody>
+          <a:bodyPr/>
+          <a:lstStyle/>
+          <a:p>
+            <a:endParaRPr lang="en-US"/>
+          </a:p>
+        </p:txBody>
       </p:sp>
       <p:pic>
         <p:nvPicPr>
@@ -1813,6 +2007,13 @@
           </a:solidFill>
           <a:ln/>
         </p:spPr>
+        <p:txBody>
+          <a:bodyPr/>
+          <a:lstStyle/>
+          <a:p>
+            <a:endParaRPr lang="en-US"/>
+          </a:p>
+        </p:txBody>
       </p:sp>
       <p:sp>
         <p:nvSpPr>
@@ -1833,6 +2034,13 @@
           </a:solidFill>
           <a:ln/>
         </p:spPr>
+        <p:txBody>
+          <a:bodyPr/>
+          <a:lstStyle/>
+          <a:p>
+            <a:endParaRPr lang="en-US"/>
+          </a:p>
+        </p:txBody>
       </p:sp>
       <p:pic>
         <p:nvPicPr>
@@ -1904,6 +2112,13 @@
           </a:solidFill>
           <a:ln/>
         </p:spPr>
+        <p:txBody>
+          <a:bodyPr/>
+          <a:lstStyle/>
+          <a:p>
+            <a:endParaRPr lang="en-US"/>
+          </a:p>
+        </p:txBody>
       </p:sp>
       <p:sp>
         <p:nvSpPr>
@@ -1924,6 +2139,13 @@
           </a:solidFill>
           <a:ln/>
         </p:spPr>
+        <p:txBody>
+          <a:bodyPr/>
+          <a:lstStyle/>
+          <a:p>
+            <a:endParaRPr lang="en-US"/>
+          </a:p>
+        </p:txBody>
       </p:sp>
       <p:pic>
         <p:nvPicPr>
@@ -1995,6 +2217,13 @@
           </a:solidFill>
           <a:ln/>
         </p:spPr>
+        <p:txBody>
+          <a:bodyPr/>
+          <a:lstStyle/>
+          <a:p>
+            <a:endParaRPr lang="en-US"/>
+          </a:p>
+        </p:txBody>
       </p:sp>
       <p:sp>
         <p:nvSpPr>
@@ -2015,6 +2244,13 @@
           </a:solidFill>
           <a:ln/>
         </p:spPr>
+        <p:txBody>
+          <a:bodyPr/>
+          <a:lstStyle/>
+          <a:p>
+            <a:endParaRPr lang="en-US"/>
+          </a:p>
+        </p:txBody>
       </p:sp>
       <p:pic>
         <p:nvPicPr>
@@ -3147,6 +3383,639 @@
   <p:cSld>
     <p:spTree>
       <p:nvGrpSpPr>
+        <p:cNvPr id="1" name="">
+          <a:extLst>
+            <a:ext uri="{FF2B5EF4-FFF2-40B4-BE49-F238E27FC236}">
+              <a16:creationId xmlns:a16="http://schemas.microsoft.com/office/drawing/2014/main" id="{A577A0F1-5D5D-846C-0DEB-34AAD86C37D8}"/>
+            </a:ext>
+          </a:extLst>
+        </p:cNvPr>
+        <p:cNvGrpSpPr/>
+        <p:nvPr/>
+      </p:nvGrpSpPr>
+      <p:grpSpPr>
+        <a:xfrm>
+          <a:off x="0" y="0"/>
+          <a:ext cx="0" cy="0"/>
+          <a:chOff x="0" y="0"/>
+          <a:chExt cx="0" cy="0"/>
+        </a:xfrm>
+      </p:grpSpPr>
+      <p:pic>
+        <p:nvPicPr>
+          <p:cNvPr id="2" name="Image 0" descr="preencoded.png">
+            <a:extLst>
+              <a:ext uri="{FF2B5EF4-FFF2-40B4-BE49-F238E27FC236}">
+                <a16:creationId xmlns:a16="http://schemas.microsoft.com/office/drawing/2014/main" id="{F4B85F87-42A0-3FF4-D9B1-2F71E96833BF}"/>
+              </a:ext>
+            </a:extLst>
+          </p:cNvPr>
+          <p:cNvPicPr>
+            <a:picLocks noChangeAspect="1"/>
+          </p:cNvPicPr>
+          <p:nvPr/>
+        </p:nvPicPr>
+        <p:blipFill>
+          <a:blip r:embed="rId3"/>
+          <a:stretch>
+            <a:fillRect/>
+          </a:stretch>
+        </p:blipFill>
+        <p:spPr>
+          <a:xfrm>
+            <a:off x="9144000" y="0"/>
+            <a:ext cx="5486400" cy="8229600"/>
+          </a:xfrm>
+          <a:prstGeom prst="rect">
+            <a:avLst/>
+          </a:prstGeom>
+        </p:spPr>
+      </p:pic>
+      <p:sp>
+        <p:nvSpPr>
+          <p:cNvPr id="3" name="Shape 0">
+            <a:extLst>
+              <a:ext uri="{FF2B5EF4-FFF2-40B4-BE49-F238E27FC236}">
+                <a16:creationId xmlns:a16="http://schemas.microsoft.com/office/drawing/2014/main" id="{B5030F7B-66AE-01E4-DF75-1E44E9FBFC96}"/>
+              </a:ext>
+            </a:extLst>
+          </p:cNvPr>
+          <p:cNvSpPr/>
+          <p:nvPr/>
+        </p:nvSpPr>
+        <p:spPr>
+          <a:xfrm>
+            <a:off x="9144000" y="0"/>
+            <a:ext cx="5486400" cy="8229600"/>
+          </a:xfrm>
+          <a:prstGeom prst="rect">
+            <a:avLst/>
+          </a:prstGeom>
+          <a:solidFill>
+            <a:srgbClr val="DFDFE0"/>
+          </a:solidFill>
+          <a:ln/>
+        </p:spPr>
+        <p:txBody>
+          <a:bodyPr/>
+          <a:lstStyle/>
+          <a:p>
+            <a:endParaRPr lang="en-US"/>
+          </a:p>
+        </p:txBody>
+      </p:sp>
+      <p:pic>
+        <p:nvPicPr>
+          <p:cNvPr id="4" name="Image 1" descr="preencoded.png">
+            <a:extLst>
+              <a:ext uri="{FF2B5EF4-FFF2-40B4-BE49-F238E27FC236}">
+                <a16:creationId xmlns:a16="http://schemas.microsoft.com/office/drawing/2014/main" id="{632D7A89-F842-3F0D-B67C-610A2DB0E36D}"/>
+              </a:ext>
+            </a:extLst>
+          </p:cNvPr>
+          <p:cNvPicPr>
+            <a:picLocks noChangeAspect="1"/>
+          </p:cNvPicPr>
+          <p:nvPr/>
+        </p:nvPicPr>
+        <p:blipFill>
+          <a:blip r:embed="rId4"/>
+          <a:stretch>
+            <a:fillRect/>
+          </a:stretch>
+        </p:blipFill>
+        <p:spPr>
+          <a:xfrm>
+            <a:off x="9144000" y="0"/>
+            <a:ext cx="5486400" cy="8229600"/>
+          </a:xfrm>
+          <a:prstGeom prst="rect">
+            <a:avLst/>
+          </a:prstGeom>
+        </p:spPr>
+      </p:pic>
+      <p:sp>
+        <p:nvSpPr>
+          <p:cNvPr id="5" name="Text 1">
+            <a:extLst>
+              <a:ext uri="{FF2B5EF4-FFF2-40B4-BE49-F238E27FC236}">
+                <a16:creationId xmlns:a16="http://schemas.microsoft.com/office/drawing/2014/main" id="{14B731FC-9CFF-FAAC-E293-B42E52FEA7FB}"/>
+              </a:ext>
+            </a:extLst>
+          </p:cNvPr>
+          <p:cNvSpPr/>
+          <p:nvPr/>
+        </p:nvSpPr>
+        <p:spPr>
+          <a:xfrm>
+            <a:off x="793790" y="1333738"/>
+            <a:ext cx="4961811" cy="620078"/>
+          </a:xfrm>
+          <a:prstGeom prst="rect">
+            <a:avLst/>
+          </a:prstGeom>
+          <a:noFill/>
+          <a:ln/>
+        </p:spPr>
+        <p:txBody>
+          <a:bodyPr wrap="none" lIns="0" tIns="0" rIns="0" bIns="0" rtlCol="0" anchor="t"/>
+          <a:lstStyle/>
+          <a:p>
+            <a:pPr marL="0" indent="0" algn="l">
+              <a:lnSpc>
+                <a:spcPts val="4850"/>
+              </a:lnSpc>
+              <a:buNone/>
+            </a:pPr>
+            <a:r>
+              <a:rPr lang="en-US" sz="3900" b="1" dirty="0">
+                <a:solidFill>
+                  <a:srgbClr val="FFFFFF"/>
+                </a:solidFill>
+                <a:latin typeface="Inter Bold" pitchFamily="34" charset="0"/>
+                <a:ea typeface="Inter Bold" pitchFamily="34" charset="-122"/>
+                <a:cs typeface="Inter Bold" pitchFamily="34" charset="-120"/>
+              </a:rPr>
+              <a:t>Key Takeaways</a:t>
+            </a:r>
+            <a:endParaRPr lang="en-US" sz="3900" dirty="0"/>
+          </a:p>
+        </p:txBody>
+      </p:sp>
+      <p:sp>
+        <p:nvSpPr>
+          <p:cNvPr id="6" name="Shape 2">
+            <a:extLst>
+              <a:ext uri="{FF2B5EF4-FFF2-40B4-BE49-F238E27FC236}">
+                <a16:creationId xmlns:a16="http://schemas.microsoft.com/office/drawing/2014/main" id="{E6500B6C-6A9A-65E0-3C47-59E89E402DD0}"/>
+              </a:ext>
+            </a:extLst>
+          </p:cNvPr>
+          <p:cNvSpPr/>
+          <p:nvPr/>
+        </p:nvSpPr>
+        <p:spPr>
+          <a:xfrm>
+            <a:off x="793790" y="2251472"/>
+            <a:ext cx="3679031" cy="1793796"/>
+          </a:xfrm>
+          <a:prstGeom prst="roundRect">
+            <a:avLst>
+              <a:gd name="adj" fmla="val 4647"/>
+            </a:avLst>
+          </a:prstGeom>
+          <a:solidFill>
+            <a:srgbClr val="110080"/>
+          </a:solidFill>
+          <a:ln w="7620">
+            <a:solidFill>
+              <a:srgbClr val="2A1999"/>
+            </a:solidFill>
+            <a:prstDash val="solid"/>
+          </a:ln>
+        </p:spPr>
+        <p:txBody>
+          <a:bodyPr/>
+          <a:lstStyle/>
+          <a:p>
+            <a:endParaRPr lang="en-US"/>
+          </a:p>
+        </p:txBody>
+      </p:sp>
+      <p:sp>
+        <p:nvSpPr>
+          <p:cNvPr id="7" name="Text 3">
+            <a:extLst>
+              <a:ext uri="{FF2B5EF4-FFF2-40B4-BE49-F238E27FC236}">
+                <a16:creationId xmlns:a16="http://schemas.microsoft.com/office/drawing/2014/main" id="{369A384F-7B3E-D571-F373-B28149F5F89E}"/>
+              </a:ext>
+            </a:extLst>
+          </p:cNvPr>
+          <p:cNvSpPr/>
+          <p:nvPr/>
+        </p:nvSpPr>
+        <p:spPr>
+          <a:xfrm>
+            <a:off x="999768" y="2457450"/>
+            <a:ext cx="3143369" cy="310158"/>
+          </a:xfrm>
+          <a:prstGeom prst="rect">
+            <a:avLst/>
+          </a:prstGeom>
+          <a:noFill/>
+          <a:ln/>
+        </p:spPr>
+        <p:txBody>
+          <a:bodyPr wrap="none" lIns="0" tIns="0" rIns="0" bIns="0" rtlCol="0" anchor="t"/>
+          <a:lstStyle/>
+          <a:p>
+            <a:pPr marL="0" indent="0" algn="l">
+              <a:lnSpc>
+                <a:spcPts val="2400"/>
+              </a:lnSpc>
+              <a:buNone/>
+            </a:pPr>
+            <a:r>
+              <a:rPr lang="en-US" sz="1950" b="1" dirty="0">
+                <a:solidFill>
+                  <a:srgbClr val="E5E0DF"/>
+                </a:solidFill>
+                <a:latin typeface="Inter Bold" pitchFamily="34" charset="0"/>
+                <a:ea typeface="Inter Bold" pitchFamily="34" charset="-122"/>
+                <a:cs typeface="Inter Bold" pitchFamily="34" charset="-120"/>
+              </a:rPr>
+              <a:t>Comprehensive Coverage</a:t>
+            </a:r>
+            <a:endParaRPr lang="en-US" sz="1950" dirty="0"/>
+          </a:p>
+        </p:txBody>
+      </p:sp>
+      <p:sp>
+        <p:nvSpPr>
+          <p:cNvPr id="8" name="Text 4">
+            <a:extLst>
+              <a:ext uri="{FF2B5EF4-FFF2-40B4-BE49-F238E27FC236}">
+                <a16:creationId xmlns:a16="http://schemas.microsoft.com/office/drawing/2014/main" id="{04AA33A9-0BB2-312A-7DFD-C57F1801713E}"/>
+              </a:ext>
+            </a:extLst>
+          </p:cNvPr>
+          <p:cNvSpPr/>
+          <p:nvPr/>
+        </p:nvSpPr>
+        <p:spPr>
+          <a:xfrm>
+            <a:off x="999768" y="2886670"/>
+            <a:ext cx="3267075" cy="952619"/>
+          </a:xfrm>
+          <a:prstGeom prst="rect">
+            <a:avLst/>
+          </a:prstGeom>
+          <a:noFill/>
+          <a:ln/>
+        </p:spPr>
+        <p:txBody>
+          <a:bodyPr wrap="square" lIns="0" tIns="0" rIns="0" bIns="0" rtlCol="0" anchor="t"/>
+          <a:lstStyle/>
+          <a:p>
+            <a:pPr marL="0" indent="0" algn="l">
+              <a:lnSpc>
+                <a:spcPts val="2500"/>
+              </a:lnSpc>
+              <a:buNone/>
+            </a:pPr>
+            <a:r>
+              <a:rPr lang="en-US" sz="1550" dirty="0">
+                <a:solidFill>
+                  <a:srgbClr val="E5E0DF"/>
+                </a:solidFill>
+                <a:latin typeface="Inter" pitchFamily="34" charset="0"/>
+                <a:ea typeface="Inter" pitchFamily="34" charset="-122"/>
+                <a:cs typeface="Inter" pitchFamily="34" charset="-120"/>
+              </a:rPr>
+              <a:t>53 test methods across 8 classes validate critical user flows from browsing to checkout</a:t>
+            </a:r>
+            <a:endParaRPr lang="en-US" sz="1550" dirty="0"/>
+          </a:p>
+        </p:txBody>
+      </p:sp>
+      <p:sp>
+        <p:nvSpPr>
+          <p:cNvPr id="9" name="Shape 5">
+            <a:extLst>
+              <a:ext uri="{FF2B5EF4-FFF2-40B4-BE49-F238E27FC236}">
+                <a16:creationId xmlns:a16="http://schemas.microsoft.com/office/drawing/2014/main" id="{C3D862C9-7A0C-AC8A-E028-8DE73BBD97B2}"/>
+              </a:ext>
+            </a:extLst>
+          </p:cNvPr>
+          <p:cNvSpPr/>
+          <p:nvPr/>
+        </p:nvSpPr>
+        <p:spPr>
+          <a:xfrm>
+            <a:off x="4671179" y="2251472"/>
+            <a:ext cx="3679031" cy="1793796"/>
+          </a:xfrm>
+          <a:prstGeom prst="roundRect">
+            <a:avLst>
+              <a:gd name="adj" fmla="val 4647"/>
+            </a:avLst>
+          </a:prstGeom>
+          <a:solidFill>
+            <a:srgbClr val="110080"/>
+          </a:solidFill>
+          <a:ln w="7620">
+            <a:solidFill>
+              <a:srgbClr val="2A1999"/>
+            </a:solidFill>
+            <a:prstDash val="solid"/>
+          </a:ln>
+        </p:spPr>
+        <p:txBody>
+          <a:bodyPr/>
+          <a:lstStyle/>
+          <a:p>
+            <a:endParaRPr lang="en-US"/>
+          </a:p>
+        </p:txBody>
+      </p:sp>
+      <p:sp>
+        <p:nvSpPr>
+          <p:cNvPr id="10" name="Text 6">
+            <a:extLst>
+              <a:ext uri="{FF2B5EF4-FFF2-40B4-BE49-F238E27FC236}">
+                <a16:creationId xmlns:a16="http://schemas.microsoft.com/office/drawing/2014/main" id="{2BFE7CC6-603C-461B-5909-6DFFAFC47CA7}"/>
+              </a:ext>
+            </a:extLst>
+          </p:cNvPr>
+          <p:cNvSpPr/>
+          <p:nvPr/>
+        </p:nvSpPr>
+        <p:spPr>
+          <a:xfrm>
+            <a:off x="4877157" y="2457450"/>
+            <a:ext cx="2480905" cy="310158"/>
+          </a:xfrm>
+          <a:prstGeom prst="rect">
+            <a:avLst/>
+          </a:prstGeom>
+          <a:noFill/>
+          <a:ln/>
+        </p:spPr>
+        <p:txBody>
+          <a:bodyPr wrap="none" lIns="0" tIns="0" rIns="0" bIns="0" rtlCol="0" anchor="t"/>
+          <a:lstStyle/>
+          <a:p>
+            <a:pPr marL="0" indent="0" algn="l">
+              <a:lnSpc>
+                <a:spcPts val="2400"/>
+              </a:lnSpc>
+              <a:buNone/>
+            </a:pPr>
+            <a:r>
+              <a:rPr lang="en-US" sz="1950" b="1" dirty="0">
+                <a:solidFill>
+                  <a:srgbClr val="E5E0DF"/>
+                </a:solidFill>
+                <a:latin typeface="Inter Bold" pitchFamily="34" charset="0"/>
+                <a:ea typeface="Inter Bold" pitchFamily="34" charset="-122"/>
+                <a:cs typeface="Inter Bold" pitchFamily="34" charset="-120"/>
+              </a:rPr>
+              <a:t>Robust Architecture</a:t>
+            </a:r>
+            <a:endParaRPr lang="en-US" sz="1950" dirty="0"/>
+          </a:p>
+        </p:txBody>
+      </p:sp>
+      <p:sp>
+        <p:nvSpPr>
+          <p:cNvPr id="11" name="Text 7">
+            <a:extLst>
+              <a:ext uri="{FF2B5EF4-FFF2-40B4-BE49-F238E27FC236}">
+                <a16:creationId xmlns:a16="http://schemas.microsoft.com/office/drawing/2014/main" id="{BE42372A-2562-4B36-38E2-DE5CA6769E99}"/>
+              </a:ext>
+            </a:extLst>
+          </p:cNvPr>
+          <p:cNvSpPr/>
+          <p:nvPr/>
+        </p:nvSpPr>
+        <p:spPr>
+          <a:xfrm>
+            <a:off x="4877157" y="2886670"/>
+            <a:ext cx="3267075" cy="952619"/>
+          </a:xfrm>
+          <a:prstGeom prst="rect">
+            <a:avLst/>
+          </a:prstGeom>
+          <a:noFill/>
+          <a:ln/>
+        </p:spPr>
+        <p:txBody>
+          <a:bodyPr wrap="square" lIns="0" tIns="0" rIns="0" bIns="0" rtlCol="0" anchor="t"/>
+          <a:lstStyle/>
+          <a:p>
+            <a:pPr marL="0" indent="0" algn="l">
+              <a:lnSpc>
+                <a:spcPts val="2500"/>
+              </a:lnSpc>
+              <a:buNone/>
+            </a:pPr>
+            <a:r>
+              <a:rPr lang="en-US" sz="1550" dirty="0">
+                <a:solidFill>
+                  <a:srgbClr val="E5E0DF"/>
+                </a:solidFill>
+                <a:latin typeface="Inter" pitchFamily="34" charset="0"/>
+                <a:ea typeface="Inter" pitchFamily="34" charset="-122"/>
+                <a:cs typeface="Inter" pitchFamily="34" charset="-120"/>
+              </a:rPr>
+              <a:t>BaseTest and TestUtils provide reusable infrastructure, reducing code duplication and maintenance</a:t>
+            </a:r>
+            <a:endParaRPr lang="en-US" sz="1550" dirty="0"/>
+          </a:p>
+        </p:txBody>
+      </p:sp>
+      <p:sp>
+        <p:nvSpPr>
+          <p:cNvPr id="12" name="Shape 8">
+            <a:extLst>
+              <a:ext uri="{FF2B5EF4-FFF2-40B4-BE49-F238E27FC236}">
+                <a16:creationId xmlns:a16="http://schemas.microsoft.com/office/drawing/2014/main" id="{E6BC0B37-E042-D490-3566-B53180C26736}"/>
+              </a:ext>
+            </a:extLst>
+          </p:cNvPr>
+          <p:cNvSpPr/>
+          <p:nvPr/>
+        </p:nvSpPr>
+        <p:spPr>
+          <a:xfrm>
+            <a:off x="793790" y="4243626"/>
+            <a:ext cx="7556421" cy="1476256"/>
+          </a:xfrm>
+          <a:prstGeom prst="roundRect">
+            <a:avLst>
+              <a:gd name="adj" fmla="val 5647"/>
+            </a:avLst>
+          </a:prstGeom>
+          <a:solidFill>
+            <a:srgbClr val="110080"/>
+          </a:solidFill>
+          <a:ln w="7620">
+            <a:solidFill>
+              <a:srgbClr val="2A1999"/>
+            </a:solidFill>
+            <a:prstDash val="solid"/>
+          </a:ln>
+        </p:spPr>
+        <p:txBody>
+          <a:bodyPr/>
+          <a:lstStyle/>
+          <a:p>
+            <a:endParaRPr lang="en-US"/>
+          </a:p>
+        </p:txBody>
+      </p:sp>
+      <p:sp>
+        <p:nvSpPr>
+          <p:cNvPr id="13" name="Text 9">
+            <a:extLst>
+              <a:ext uri="{FF2B5EF4-FFF2-40B4-BE49-F238E27FC236}">
+                <a16:creationId xmlns:a16="http://schemas.microsoft.com/office/drawing/2014/main" id="{9E80ADE8-AED6-1643-03CF-2C0DFA9C90C3}"/>
+              </a:ext>
+            </a:extLst>
+          </p:cNvPr>
+          <p:cNvSpPr/>
+          <p:nvPr/>
+        </p:nvSpPr>
+        <p:spPr>
+          <a:xfrm>
+            <a:off x="999768" y="4449604"/>
+            <a:ext cx="2826425" cy="310158"/>
+          </a:xfrm>
+          <a:prstGeom prst="rect">
+            <a:avLst/>
+          </a:prstGeom>
+          <a:noFill/>
+          <a:ln/>
+        </p:spPr>
+        <p:txBody>
+          <a:bodyPr wrap="none" lIns="0" tIns="0" rIns="0" bIns="0" rtlCol="0" anchor="t"/>
+          <a:lstStyle/>
+          <a:p>
+            <a:pPr marL="0" indent="0" algn="l">
+              <a:lnSpc>
+                <a:spcPts val="2400"/>
+              </a:lnSpc>
+              <a:buNone/>
+            </a:pPr>
+            <a:r>
+              <a:rPr lang="en-US" sz="1950" b="1" dirty="0">
+                <a:solidFill>
+                  <a:srgbClr val="E5E0DF"/>
+                </a:solidFill>
+                <a:latin typeface="Inter Bold" pitchFamily="34" charset="0"/>
+                <a:ea typeface="Inter Bold" pitchFamily="34" charset="-122"/>
+                <a:cs typeface="Inter Bold" pitchFamily="34" charset="-120"/>
+              </a:rPr>
+              <a:t>Real-World Constraints</a:t>
+            </a:r>
+            <a:endParaRPr lang="en-US" sz="1950" dirty="0"/>
+          </a:p>
+        </p:txBody>
+      </p:sp>
+      <p:sp>
+        <p:nvSpPr>
+          <p:cNvPr id="14" name="Text 10">
+            <a:extLst>
+              <a:ext uri="{FF2B5EF4-FFF2-40B4-BE49-F238E27FC236}">
+                <a16:creationId xmlns:a16="http://schemas.microsoft.com/office/drawing/2014/main" id="{EE11742D-127E-5132-D156-6D88824AF9CD}"/>
+              </a:ext>
+            </a:extLst>
+          </p:cNvPr>
+          <p:cNvSpPr/>
+          <p:nvPr/>
+        </p:nvSpPr>
+        <p:spPr>
+          <a:xfrm>
+            <a:off x="999768" y="4878824"/>
+            <a:ext cx="7144464" cy="635079"/>
+          </a:xfrm>
+          <a:prstGeom prst="rect">
+            <a:avLst/>
+          </a:prstGeom>
+          <a:noFill/>
+          <a:ln/>
+        </p:spPr>
+        <p:txBody>
+          <a:bodyPr wrap="square" lIns="0" tIns="0" rIns="0" bIns="0" rtlCol="0" anchor="t"/>
+          <a:lstStyle/>
+          <a:p>
+            <a:pPr marL="0" indent="0" algn="l">
+              <a:lnSpc>
+                <a:spcPts val="2500"/>
+              </a:lnSpc>
+              <a:buNone/>
+            </a:pPr>
+            <a:r>
+              <a:rPr lang="en-US" sz="1550" dirty="0">
+                <a:solidFill>
+                  <a:srgbClr val="E5E0DF"/>
+                </a:solidFill>
+                <a:latin typeface="Inter" pitchFamily="34" charset="0"/>
+                <a:ea typeface="Inter" pitchFamily="34" charset="-122"/>
+                <a:cs typeface="Inter" pitchFamily="34" charset="-120"/>
+              </a:rPr>
+              <a:t>Successfully handled GDPR, CAPTCHA, age-gates, lazy-loading, and anti-automation detection</a:t>
+            </a:r>
+            <a:endParaRPr lang="en-US" sz="1550" dirty="0"/>
+          </a:p>
+        </p:txBody>
+      </p:sp>
+      <p:sp>
+        <p:nvSpPr>
+          <p:cNvPr id="15" name="Text 11">
+            <a:extLst>
+              <a:ext uri="{FF2B5EF4-FFF2-40B4-BE49-F238E27FC236}">
+                <a16:creationId xmlns:a16="http://schemas.microsoft.com/office/drawing/2014/main" id="{2E81F54F-BF5C-27A8-22EB-33A71C42497D}"/>
+              </a:ext>
+            </a:extLst>
+          </p:cNvPr>
+          <p:cNvSpPr/>
+          <p:nvPr/>
+        </p:nvSpPr>
+        <p:spPr>
+          <a:xfrm>
+            <a:off x="793790" y="5943124"/>
+            <a:ext cx="7556421" cy="952619"/>
+          </a:xfrm>
+          <a:prstGeom prst="rect">
+            <a:avLst/>
+          </a:prstGeom>
+          <a:noFill/>
+          <a:ln/>
+        </p:spPr>
+        <p:txBody>
+          <a:bodyPr wrap="square" lIns="0" tIns="0" rIns="0" bIns="0" rtlCol="0" anchor="t"/>
+          <a:lstStyle/>
+          <a:p>
+            <a:pPr marL="0" indent="0" algn="l">
+              <a:lnSpc>
+                <a:spcPts val="2500"/>
+              </a:lnSpc>
+              <a:buNone/>
+            </a:pPr>
+            <a:r>
+              <a:rPr lang="en-US" sz="1550" dirty="0">
+                <a:solidFill>
+                  <a:srgbClr val="E5E0DF"/>
+                </a:solidFill>
+                <a:latin typeface="Inter" pitchFamily="34" charset="0"/>
+                <a:ea typeface="Inter" pitchFamily="34" charset="-122"/>
+                <a:cs typeface="Inter" pitchFamily="34" charset="-120"/>
+              </a:rPr>
+              <a:t>This automated test suite establishes a repeatable regression baseline for GOG.com, improving product quality confidence and reducing manual testing burden.</a:t>
+            </a:r>
+            <a:endParaRPr lang="en-US" sz="1550" dirty="0"/>
+          </a:p>
+        </p:txBody>
+      </p:sp>
+    </p:spTree>
+    <p:extLst>
+      <p:ext uri="{BB962C8B-B14F-4D97-AF65-F5344CB8AC3E}">
+        <p14:creationId xmlns:p14="http://schemas.microsoft.com/office/powerpoint/2010/main" val="4250509548"/>
+      </p:ext>
+    </p:extLst>
+  </p:cSld>
+  <p:clrMapOvr>
+    <a:masterClrMapping/>
+  </p:clrMapOvr>
+</p:sld>
+</file>
+
+<file path=ppt/slides/slide12.xml><?xml version="1.0" encoding="utf-8"?>
+<p:sld xmlns:a="http://schemas.openxmlformats.org/drawingml/2006/main" xmlns:r="http://schemas.openxmlformats.org/officeDocument/2006/relationships" xmlns:p="http://schemas.openxmlformats.org/presentationml/2006/main">
+  <p:cSld>
+    <p:spTree>
+      <p:nvGrpSpPr>
         <p:cNvPr id="1" name=""/>
         <p:cNvGrpSpPr/>
         <p:nvPr/>
@@ -3159,10 +4028,198 @@
           <a:chExt cx="0" cy="0"/>
         </a:xfrm>
       </p:grpSpPr>
+      <p:pic>
+        <p:nvPicPr>
+          <p:cNvPr id="3" name="Picture 2">
+            <a:extLst>
+              <a:ext uri="{FF2B5EF4-FFF2-40B4-BE49-F238E27FC236}">
+                <a16:creationId xmlns:a16="http://schemas.microsoft.com/office/drawing/2014/main" id="{9AC9DA1E-25B3-B8DB-32D1-D828C6418390}"/>
+              </a:ext>
+            </a:extLst>
+          </p:cNvPr>
+          <p:cNvPicPr/>
+          <p:nvPr/>
+        </p:nvPicPr>
+        <p:blipFill>
+          <a:blip r:embed="rId2"/>
+          <a:stretch>
+            <a:fillRect/>
+          </a:stretch>
+        </p:blipFill>
+        <p:spPr>
+          <a:xfrm>
+            <a:off x="11620080" y="7715178"/>
+            <a:ext cx="3010320" cy="514422"/>
+          </a:xfrm>
+          <a:prstGeom prst="rect">
+            <a:avLst/>
+          </a:prstGeom>
+        </p:spPr>
+      </p:pic>
+      <p:sp>
+        <p:nvSpPr>
+          <p:cNvPr id="4" name="Text 1">
+            <a:extLst>
+              <a:ext uri="{FF2B5EF4-FFF2-40B4-BE49-F238E27FC236}">
+                <a16:creationId xmlns:a16="http://schemas.microsoft.com/office/drawing/2014/main" id="{795315F3-4A4C-1431-1821-39024AEA05FE}"/>
+              </a:ext>
+            </a:extLst>
+          </p:cNvPr>
+          <p:cNvSpPr/>
+          <p:nvPr/>
+        </p:nvSpPr>
+        <p:spPr>
+          <a:xfrm>
+            <a:off x="793790" y="1333738"/>
+            <a:ext cx="4961811" cy="620078"/>
+          </a:xfrm>
+          <a:prstGeom prst="rect">
+            <a:avLst/>
+          </a:prstGeom>
+          <a:noFill/>
+          <a:ln/>
+        </p:spPr>
+        <p:txBody>
+          <a:bodyPr wrap="none" lIns="0" tIns="0" rIns="0" bIns="0" rtlCol="0" anchor="t"/>
+          <a:lstStyle/>
+          <a:p>
+            <a:pPr marL="0" indent="0" algn="l">
+              <a:lnSpc>
+                <a:spcPts val="4850"/>
+              </a:lnSpc>
+              <a:buNone/>
+            </a:pPr>
+            <a:r>
+              <a:rPr lang="en-US" sz="3900" b="1" dirty="0">
+                <a:solidFill>
+                  <a:srgbClr val="FFFFFF"/>
+                </a:solidFill>
+                <a:latin typeface="Inter Bold" pitchFamily="34" charset="0"/>
+                <a:ea typeface="Inter Bold" pitchFamily="34" charset="-122"/>
+                <a:cs typeface="Inter Bold" pitchFamily="34" charset="-120"/>
+              </a:rPr>
+              <a:t>Future Improvements</a:t>
+            </a:r>
+            <a:endParaRPr lang="en-US" sz="3900" dirty="0"/>
+          </a:p>
+        </p:txBody>
+      </p:sp>
     </p:spTree>
     <p:extLst>
       <p:ext uri="{BB962C8B-B14F-4D97-AF65-F5344CB8AC3E}">
-        <p14:creationId xmlns:p14="http://schemas.microsoft.com/office/powerpoint/2010/main" val="1212672210"/>
+        <p14:creationId xmlns:p14="http://schemas.microsoft.com/office/powerpoint/2010/main" val="1547293548"/>
+      </p:ext>
+    </p:extLst>
+  </p:cSld>
+  <p:clrMapOvr>
+    <a:masterClrMapping/>
+  </p:clrMapOvr>
+</p:sld>
+</file>
+
+<file path=ppt/slides/slide13.xml><?xml version="1.0" encoding="utf-8"?>
+<p:sld xmlns:a="http://schemas.openxmlformats.org/drawingml/2006/main" xmlns:r="http://schemas.openxmlformats.org/officeDocument/2006/relationships" xmlns:p="http://schemas.openxmlformats.org/presentationml/2006/main">
+  <p:cSld>
+    <p:spTree>
+      <p:nvGrpSpPr>
+        <p:cNvPr id="1" name="">
+          <a:extLst>
+            <a:ext uri="{FF2B5EF4-FFF2-40B4-BE49-F238E27FC236}">
+              <a16:creationId xmlns:a16="http://schemas.microsoft.com/office/drawing/2014/main" id="{5DE67DC1-25F9-D168-231A-5F62C702F798}"/>
+            </a:ext>
+          </a:extLst>
+        </p:cNvPr>
+        <p:cNvGrpSpPr/>
+        <p:nvPr/>
+      </p:nvGrpSpPr>
+      <p:grpSpPr>
+        <a:xfrm>
+          <a:off x="0" y="0"/>
+          <a:ext cx="0" cy="0"/>
+          <a:chOff x="0" y="0"/>
+          <a:chExt cx="0" cy="0"/>
+        </a:xfrm>
+      </p:grpSpPr>
+      <p:pic>
+        <p:nvPicPr>
+          <p:cNvPr id="3" name="Picture 2">
+            <a:extLst>
+              <a:ext uri="{FF2B5EF4-FFF2-40B4-BE49-F238E27FC236}">
+                <a16:creationId xmlns:a16="http://schemas.microsoft.com/office/drawing/2014/main" id="{EC60CFC5-3A9C-76F6-950F-F2F6F5611650}"/>
+              </a:ext>
+            </a:extLst>
+          </p:cNvPr>
+          <p:cNvPicPr/>
+          <p:nvPr/>
+        </p:nvPicPr>
+        <p:blipFill>
+          <a:blip r:embed="rId2"/>
+          <a:stretch>
+            <a:fillRect/>
+          </a:stretch>
+        </p:blipFill>
+        <p:spPr>
+          <a:xfrm>
+            <a:off x="11620080" y="7715178"/>
+            <a:ext cx="3010320" cy="514422"/>
+          </a:xfrm>
+          <a:prstGeom prst="rect">
+            <a:avLst/>
+          </a:prstGeom>
+        </p:spPr>
+      </p:pic>
+      <p:sp>
+        <p:nvSpPr>
+          <p:cNvPr id="4" name="Text 1">
+            <a:extLst>
+              <a:ext uri="{FF2B5EF4-FFF2-40B4-BE49-F238E27FC236}">
+                <a16:creationId xmlns:a16="http://schemas.microsoft.com/office/drawing/2014/main" id="{00F4F32A-EA87-6BD3-8429-D0B1A87F383F}"/>
+              </a:ext>
+            </a:extLst>
+          </p:cNvPr>
+          <p:cNvSpPr/>
+          <p:nvPr/>
+        </p:nvSpPr>
+        <p:spPr>
+          <a:xfrm>
+            <a:off x="793790" y="1333738"/>
+            <a:ext cx="4961811" cy="620078"/>
+          </a:xfrm>
+          <a:prstGeom prst="rect">
+            <a:avLst/>
+          </a:prstGeom>
+          <a:noFill/>
+          <a:ln/>
+        </p:spPr>
+        <p:txBody>
+          <a:bodyPr wrap="none" lIns="0" tIns="0" rIns="0" bIns="0" rtlCol="0" anchor="t"/>
+          <a:lstStyle/>
+          <a:p>
+            <a:pPr marL="0" indent="0" algn="l">
+              <a:lnSpc>
+                <a:spcPts val="4850"/>
+              </a:lnSpc>
+              <a:buNone/>
+            </a:pPr>
+            <a:r>
+              <a:rPr lang="en-US" sz="3900" b="1" dirty="0">
+                <a:solidFill>
+                  <a:srgbClr val="FFFFFF"/>
+                </a:solidFill>
+                <a:latin typeface="Inter Bold" pitchFamily="34" charset="0"/>
+                <a:ea typeface="Inter Bold" pitchFamily="34" charset="-122"/>
+                <a:cs typeface="Inter Bold" pitchFamily="34" charset="-120"/>
+              </a:rPr>
+              <a:t>Conclusion</a:t>
+            </a:r>
+            <a:endParaRPr lang="en-US" sz="3900" dirty="0"/>
+          </a:p>
+        </p:txBody>
+      </p:sp>
+    </p:spTree>
+    <p:extLst>
+      <p:ext uri="{BB962C8B-B14F-4D97-AF65-F5344CB8AC3E}">
+        <p14:creationId xmlns:p14="http://schemas.microsoft.com/office/powerpoint/2010/main" val="2124667151"/>
       </p:ext>
     </p:extLst>
   </p:cSld>
@@ -3981,6 +5038,34 @@
           </a:p>
         </p:txBody>
       </p:sp>
+      <p:pic>
+        <p:nvPicPr>
+          <p:cNvPr id="24" name="Picture 23">
+            <a:extLst>
+              <a:ext uri="{FF2B5EF4-FFF2-40B4-BE49-F238E27FC236}">
+                <a16:creationId xmlns:a16="http://schemas.microsoft.com/office/drawing/2014/main" id="{18A7C5FB-B504-B4FE-8895-1B809187D571}"/>
+              </a:ext>
+            </a:extLst>
+          </p:cNvPr>
+          <p:cNvPicPr/>
+          <p:nvPr/>
+        </p:nvPicPr>
+        <p:blipFill>
+          <a:blip r:embed="rId7"/>
+          <a:stretch>
+            <a:fillRect/>
+          </a:stretch>
+        </p:blipFill>
+        <p:spPr>
+          <a:xfrm>
+            <a:off x="11620080" y="7715178"/>
+            <a:ext cx="3010320" cy="514422"/>
+          </a:xfrm>
+          <a:prstGeom prst="rect">
+            <a:avLst/>
+          </a:prstGeom>
+        </p:spPr>
+      </p:pic>
     </p:spTree>
   </p:cSld>
   <p:clrMapOvr>
@@ -4912,6 +5997,34 @@
           </a:p>
         </p:txBody>
       </p:sp>
+      <p:pic>
+        <p:nvPicPr>
+          <p:cNvPr id="27" name="Picture 26">
+            <a:extLst>
+              <a:ext uri="{FF2B5EF4-FFF2-40B4-BE49-F238E27FC236}">
+                <a16:creationId xmlns:a16="http://schemas.microsoft.com/office/drawing/2014/main" id="{D8917F21-0991-B79F-02DB-ECBA3B61B84F}"/>
+              </a:ext>
+            </a:extLst>
+          </p:cNvPr>
+          <p:cNvPicPr/>
+          <p:nvPr/>
+        </p:nvPicPr>
+        <p:blipFill>
+          <a:blip r:embed="rId4"/>
+          <a:stretch>
+            <a:fillRect/>
+          </a:stretch>
+        </p:blipFill>
+        <p:spPr>
+          <a:xfrm>
+            <a:off x="11620080" y="7715178"/>
+            <a:ext cx="3010320" cy="514422"/>
+          </a:xfrm>
+          <a:prstGeom prst="rect">
+            <a:avLst/>
+          </a:prstGeom>
+        </p:spPr>
+      </p:pic>
     </p:spTree>
   </p:cSld>
   <p:clrMapOvr>
@@ -5381,6 +6494,34 @@
           </a:p>
         </p:txBody>
       </p:sp>
+      <p:pic>
+        <p:nvPicPr>
+          <p:cNvPr id="9" name="Picture 8">
+            <a:extLst>
+              <a:ext uri="{FF2B5EF4-FFF2-40B4-BE49-F238E27FC236}">
+                <a16:creationId xmlns:a16="http://schemas.microsoft.com/office/drawing/2014/main" id="{2B000B29-4400-6104-3BB4-A902716E0686}"/>
+              </a:ext>
+            </a:extLst>
+          </p:cNvPr>
+          <p:cNvPicPr/>
+          <p:nvPr/>
+        </p:nvPicPr>
+        <p:blipFill>
+          <a:blip r:embed="rId3"/>
+          <a:stretch>
+            <a:fillRect/>
+          </a:stretch>
+        </p:blipFill>
+        <p:spPr>
+          <a:xfrm>
+            <a:off x="11620080" y="7715178"/>
+            <a:ext cx="3010320" cy="514422"/>
+          </a:xfrm>
+          <a:prstGeom prst="rect">
+            <a:avLst/>
+          </a:prstGeom>
+        </p:spPr>
+      </p:pic>
     </p:spTree>
   </p:cSld>
   <p:clrMapOvr>
@@ -6474,6 +7615,34 @@
           </a:p>
         </p:txBody>
       </p:sp>
+      <p:pic>
+        <p:nvPicPr>
+          <p:cNvPr id="30" name="Picture 29">
+            <a:extLst>
+              <a:ext uri="{FF2B5EF4-FFF2-40B4-BE49-F238E27FC236}">
+                <a16:creationId xmlns:a16="http://schemas.microsoft.com/office/drawing/2014/main" id="{94123A21-2192-F206-E68A-3635B3B33AB2}"/>
+              </a:ext>
+            </a:extLst>
+          </p:cNvPr>
+          <p:cNvPicPr/>
+          <p:nvPr/>
+        </p:nvPicPr>
+        <p:blipFill>
+          <a:blip r:embed="rId12"/>
+          <a:stretch>
+            <a:fillRect/>
+          </a:stretch>
+        </p:blipFill>
+        <p:spPr>
+          <a:xfrm>
+            <a:off x="11620080" y="7715178"/>
+            <a:ext cx="3010320" cy="514422"/>
+          </a:xfrm>
+          <a:prstGeom prst="rect">
+            <a:avLst/>
+          </a:prstGeom>
+        </p:spPr>
+      </p:pic>
     </p:spTree>
   </p:cSld>
   <p:clrMapOvr>
@@ -6841,7 +8010,7 @@
         </p:nvSpPr>
         <p:spPr>
           <a:xfrm>
-            <a:off x="719376" y="5437346"/>
+            <a:off x="662702" y="5437346"/>
             <a:ext cx="13191649" cy="2262426"/>
           </a:xfrm>
           <a:prstGeom prst="rect">
@@ -7002,6 +8171,34 @@
           </a:p>
         </p:txBody>
       </p:sp>
+      <p:pic>
+        <p:nvPicPr>
+          <p:cNvPr id="8" name="Picture 7">
+            <a:extLst>
+              <a:ext uri="{FF2B5EF4-FFF2-40B4-BE49-F238E27FC236}">
+                <a16:creationId xmlns:a16="http://schemas.microsoft.com/office/drawing/2014/main" id="{769CC082-DB5E-7448-1187-C7C02E72CE0C}"/>
+              </a:ext>
+            </a:extLst>
+          </p:cNvPr>
+          <p:cNvPicPr/>
+          <p:nvPr/>
+        </p:nvPicPr>
+        <p:blipFill>
+          <a:blip r:embed="rId4"/>
+          <a:stretch>
+            <a:fillRect/>
+          </a:stretch>
+        </p:blipFill>
+        <p:spPr>
+          <a:xfrm>
+            <a:off x="11620080" y="7715178"/>
+            <a:ext cx="3010320" cy="514422"/>
+          </a:xfrm>
+          <a:prstGeom prst="rect">
+            <a:avLst/>
+          </a:prstGeom>
+        </p:spPr>
+      </p:pic>
     </p:spTree>
   </p:cSld>
   <p:clrMapOvr>
@@ -7951,6 +9148,36 @@
           </a:p>
         </p:txBody>
       </p:sp>
+      <p:pic>
+        <p:nvPicPr>
+          <p:cNvPr id="28" name="Picture 27">
+            <a:extLst>
+              <a:ext uri="{FF2B5EF4-FFF2-40B4-BE49-F238E27FC236}">
+                <a16:creationId xmlns:a16="http://schemas.microsoft.com/office/drawing/2014/main" id="{C5EB001D-19EB-60E0-9084-1C7339D931E5}"/>
+              </a:ext>
+            </a:extLst>
+          </p:cNvPr>
+          <p:cNvPicPr>
+            <a:picLocks noGrp="1" noRot="1" noChangeAspect="1" noMove="1" noResize="1" noEditPoints="1" noAdjustHandles="1" noChangeArrowheads="1" noChangeShapeType="1" noCrop="1"/>
+          </p:cNvPicPr>
+          <p:nvPr/>
+        </p:nvPicPr>
+        <p:blipFill>
+          <a:blip r:embed="rId3"/>
+          <a:stretch>
+            <a:fillRect/>
+          </a:stretch>
+        </p:blipFill>
+        <p:spPr>
+          <a:xfrm>
+            <a:off x="11620080" y="7715178"/>
+            <a:ext cx="3010320" cy="514422"/>
+          </a:xfrm>
+          <a:prstGeom prst="rect">
+            <a:avLst/>
+          </a:prstGeom>
+        </p:spPr>
+      </p:pic>
     </p:spTree>
   </p:cSld>
   <p:clrMapOvr>

</xml_diff>